<commit_message>
Updated final presentation in final products folder
</commit_message>
<xml_diff>
--- a/Final_Products/Masters_Capstone_Final_Presentation.pptx
+++ b/Final_Products/Masters_Capstone_Final_Presentation.pptx
@@ -207,7 +207,7 @@
   <pc:docChgLst>
     <pc:chgData name="Madison Jones" userId="4347cae8-7c2b-4706-9465-46f5e461052a" providerId="ADAL" clId="{23AD2B71-142B-4412-B515-82A4DB346E58}"/>
     <pc:docChg chg="undo custSel addSld delSld modSld sldOrd">
-      <pc:chgData name="Madison Jones" userId="4347cae8-7c2b-4706-9465-46f5e461052a" providerId="ADAL" clId="{23AD2B71-142B-4412-B515-82A4DB346E58}" dt="2026-05-08T04:37:41.448" v="5145" actId="1076"/>
+      <pc:chgData name="Madison Jones" userId="4347cae8-7c2b-4706-9465-46f5e461052a" providerId="ADAL" clId="{23AD2B71-142B-4412-B515-82A4DB346E58}" dt="2026-05-08T16:42:32.978" v="5148" actId="15"/>
       <pc:docMkLst>
         <pc:docMk/>
       </pc:docMkLst>
@@ -376,13 +376,13 @@
         </pc:picChg>
       </pc:sldChg>
       <pc:sldChg chg="modSp mod">
-        <pc:chgData name="Madison Jones" userId="4347cae8-7c2b-4706-9465-46f5e461052a" providerId="ADAL" clId="{23AD2B71-142B-4412-B515-82A4DB346E58}" dt="2026-05-08T02:25:35.884" v="76" actId="20577"/>
+        <pc:chgData name="Madison Jones" userId="4347cae8-7c2b-4706-9465-46f5e461052a" providerId="ADAL" clId="{23AD2B71-142B-4412-B515-82A4DB346E58}" dt="2026-05-08T16:42:14.374" v="5147" actId="15"/>
         <pc:sldMkLst>
           <pc:docMk/>
           <pc:sldMk cId="1220674455" sldId="531"/>
         </pc:sldMkLst>
         <pc:spChg chg="mod">
-          <ac:chgData name="Madison Jones" userId="4347cae8-7c2b-4706-9465-46f5e461052a" providerId="ADAL" clId="{23AD2B71-142B-4412-B515-82A4DB346E58}" dt="2026-05-08T02:25:35.884" v="76" actId="20577"/>
+          <ac:chgData name="Madison Jones" userId="4347cae8-7c2b-4706-9465-46f5e461052a" providerId="ADAL" clId="{23AD2B71-142B-4412-B515-82A4DB346E58}" dt="2026-05-08T16:42:14.374" v="5147" actId="15"/>
           <ac:spMkLst>
             <pc:docMk/>
             <pc:sldMk cId="1220674455" sldId="531"/>
@@ -413,13 +413,13 @@
         </pc:spChg>
       </pc:sldChg>
       <pc:sldChg chg="modSp mod">
-        <pc:chgData name="Madison Jones" userId="4347cae8-7c2b-4706-9465-46f5e461052a" providerId="ADAL" clId="{23AD2B71-142B-4412-B515-82A4DB346E58}" dt="2026-05-08T04:11:34.058" v="4484" actId="20577"/>
+        <pc:chgData name="Madison Jones" userId="4347cae8-7c2b-4706-9465-46f5e461052a" providerId="ADAL" clId="{23AD2B71-142B-4412-B515-82A4DB346E58}" dt="2026-05-08T16:42:32.978" v="5148" actId="15"/>
         <pc:sldMkLst>
           <pc:docMk/>
           <pc:sldMk cId="4207931579" sldId="546"/>
         </pc:sldMkLst>
         <pc:spChg chg="mod">
-          <ac:chgData name="Madison Jones" userId="4347cae8-7c2b-4706-9465-46f5e461052a" providerId="ADAL" clId="{23AD2B71-142B-4412-B515-82A4DB346E58}" dt="2026-05-08T04:11:34.058" v="4484" actId="20577"/>
+          <ac:chgData name="Madison Jones" userId="4347cae8-7c2b-4706-9465-46f5e461052a" providerId="ADAL" clId="{23AD2B71-142B-4412-B515-82A4DB346E58}" dt="2026-05-08T16:42:32.978" v="5148" actId="15"/>
           <ac:spMkLst>
             <pc:docMk/>
             <pc:sldMk cId="4207931579" sldId="546"/>
@@ -848,7 +848,7 @@
           <a:p>
             <a:fld id="{1C830E4C-56B7-2443-B370-610F8D1BCD9C}" type="datetimeFigureOut">
               <a:rPr lang="en-US" smtClean="0"/>
-              <a:t>5/7/2026</a:t>
+              <a:t>5/8/2026</a:t>
             </a:fld>
             <a:endParaRPr lang="en-US" dirty="0"/>
           </a:p>
@@ -1025,7 +1025,7 @@
           <a:p>
             <a:fld id="{CBCD2FD1-B169-9B41-A890-0ECD81C3476C}" type="datetimeFigureOut">
               <a:rPr lang="en-US" smtClean="0"/>
-              <a:t>5/7/2026</a:t>
+              <a:t>5/8/2026</a:t>
             </a:fld>
             <a:endParaRPr lang="en-US" dirty="0"/>
           </a:p>
@@ -6782,13 +6782,10 @@
             </a:r>
           </a:p>
           <a:p>
-            <a:r>
-              <a:rPr lang="en-US" b="1" dirty="0"/>
-              <a:t>I</a:t>
-            </a:r>
+            <a:pPr lvl="1"/>
             <a:r>
               <a:rPr lang="en-US" dirty="0"/>
-              <a:t>n the absence of treatment, treatment and control groups would trend the same way over time </a:t>
+              <a:t>In the absence of treatment, treatment and control groups would trend the same way over time </a:t>
             </a:r>
           </a:p>
           <a:p>
@@ -6914,8 +6911,8 @@
           </a:p>
         </p:txBody>
       </p:sp>
-      <mc:AlternateContent xmlns:mc="http://schemas.openxmlformats.org/markup-compatibility/2006">
-        <mc:Choice xmlns:a14="http://schemas.microsoft.com/office/drawing/2010/main" Requires="a14">
+      <mc:AlternateContent xmlns:mc="http://schemas.openxmlformats.org/markup-compatibility/2006" xmlns:a14="http://schemas.microsoft.com/office/drawing/2010/main">
+        <mc:Choice Requires="a14">
           <p:sp>
             <p:nvSpPr>
               <p:cNvPr id="4" name="Content Placeholder 3">
@@ -7373,7 +7370,7 @@
             </p:txBody>
           </p:sp>
         </mc:Choice>
-        <mc:Fallback>
+        <mc:Fallback xmlns="">
           <p:sp>
             <p:nvSpPr>
               <p:cNvPr id="4" name="Content Placeholder 3">
@@ -7509,8 +7506,8 @@
           </a:p>
         </p:txBody>
       </p:sp>
-      <mc:AlternateContent xmlns:mc="http://schemas.openxmlformats.org/markup-compatibility/2006">
-        <mc:Choice xmlns:a14="http://schemas.microsoft.com/office/drawing/2010/main" Requires="a14">
+      <mc:AlternateContent xmlns:mc="http://schemas.openxmlformats.org/markup-compatibility/2006" xmlns:a14="http://schemas.microsoft.com/office/drawing/2010/main">
+        <mc:Choice Requires="a14">
           <p:sp>
             <p:nvSpPr>
               <p:cNvPr id="4" name="Content Placeholder 3">
@@ -7555,111 +7552,153 @@
                       <m:sSub>
                         <m:sSubPr>
                           <m:ctrlPr>
-                            <a:rPr lang="en-US" i="1"/>
+                            <a:rPr lang="en-US" i="1">
+                              <a:latin typeface="Cambria Math" panose="02040503050406030204" pitchFamily="18" charset="0"/>
+                            </a:rPr>
                           </m:ctrlPr>
                         </m:sSubPr>
                         <m:e>
                           <m:r>
-                            <a:rPr lang="en-US" i="1"/>
+                            <a:rPr lang="en-US" i="1">
+                              <a:latin typeface="Cambria Math" panose="02040503050406030204" pitchFamily="18" charset="0"/>
+                            </a:rPr>
                             <m:t>𝑀𝑒𝑎𝑛</m:t>
                           </m:r>
                           <m:r>
-                            <a:rPr lang="en-US" i="1"/>
+                            <a:rPr lang="en-US" i="1">
+                              <a:latin typeface="Cambria Math" panose="02040503050406030204" pitchFamily="18" charset="0"/>
+                            </a:rPr>
                             <m:t> </m:t>
                           </m:r>
                           <m:r>
-                            <a:rPr lang="en-US" i="1"/>
+                            <a:rPr lang="en-US" i="1">
+                              <a:latin typeface="Cambria Math" panose="02040503050406030204" pitchFamily="18" charset="0"/>
+                            </a:rPr>
                             <m:t>𝑆𝑐𝑎𝑙𝑒</m:t>
                           </m:r>
                           <m:r>
-                            <a:rPr lang="en-US" i="1"/>
+                            <a:rPr lang="en-US" i="1">
+                              <a:latin typeface="Cambria Math" panose="02040503050406030204" pitchFamily="18" charset="0"/>
+                            </a:rPr>
                             <m:t> </m:t>
                           </m:r>
                           <m:r>
-                            <a:rPr lang="en-US" i="1"/>
+                            <a:rPr lang="en-US" i="1">
+                              <a:latin typeface="Cambria Math" panose="02040503050406030204" pitchFamily="18" charset="0"/>
+                            </a:rPr>
                             <m:t>𝑆𝑐𝑜𝑟𝑒</m:t>
                           </m:r>
                         </m:e>
                         <m:sub>
                           <m:r>
-                            <a:rPr lang="en-US" i="1"/>
+                            <a:rPr lang="en-US" i="1">
+                              <a:latin typeface="Cambria Math" panose="02040503050406030204" pitchFamily="18" charset="0"/>
+                            </a:rPr>
                             <m:t>𝑖</m:t>
                           </m:r>
                           <m:r>
-                            <a:rPr lang="en-US" i="1"/>
+                            <a:rPr lang="en-US" i="1">
+                              <a:latin typeface="Cambria Math" panose="02040503050406030204" pitchFamily="18" charset="0"/>
+                            </a:rPr>
                             <m:t>,</m:t>
                           </m:r>
                           <m:r>
-                            <a:rPr lang="en-US" i="1"/>
+                            <a:rPr lang="en-US" i="1">
+                              <a:latin typeface="Cambria Math" panose="02040503050406030204" pitchFamily="18" charset="0"/>
+                            </a:rPr>
                             <m:t>𝑡</m:t>
                           </m:r>
                         </m:sub>
                       </m:sSub>
                       <m:r>
-                        <a:rPr lang="en-US" i="1"/>
+                        <a:rPr lang="en-US" i="1">
+                          <a:latin typeface="Cambria Math" panose="02040503050406030204" pitchFamily="18" charset="0"/>
+                        </a:rPr>
                         <m:t>= </m:t>
                       </m:r>
                       <m:sSub>
                         <m:sSubPr>
                           <m:ctrlPr>
-                            <a:rPr lang="en-US" i="1"/>
+                            <a:rPr lang="en-US" i="1">
+                              <a:latin typeface="Cambria Math" panose="02040503050406030204" pitchFamily="18" charset="0"/>
+                            </a:rPr>
                           </m:ctrlPr>
                         </m:sSubPr>
                         <m:e>
                           <m:r>
-                            <a:rPr lang="en-US" i="1"/>
+                            <a:rPr lang="en-US" i="1">
+                              <a:latin typeface="Cambria Math" panose="02040503050406030204" pitchFamily="18" charset="0"/>
+                            </a:rPr>
                             <m:t>𝛼</m:t>
                           </m:r>
                         </m:e>
                         <m:sub>
                           <m:r>
-                            <a:rPr lang="en-US" i="1"/>
+                            <a:rPr lang="en-US" i="1">
+                              <a:latin typeface="Cambria Math" panose="02040503050406030204" pitchFamily="18" charset="0"/>
+                            </a:rPr>
                             <m:t>𝑖</m:t>
                           </m:r>
                         </m:sub>
                       </m:sSub>
                       <m:r>
-                        <a:rPr lang="en-US" i="1"/>
+                        <a:rPr lang="en-US" i="1">
+                          <a:latin typeface="Cambria Math" panose="02040503050406030204" pitchFamily="18" charset="0"/>
+                        </a:rPr>
                         <m:t>+</m:t>
                       </m:r>
                       <m:sSub>
                         <m:sSubPr>
                           <m:ctrlPr>
-                            <a:rPr lang="en-US" i="1"/>
+                            <a:rPr lang="en-US" i="1">
+                              <a:latin typeface="Cambria Math" panose="02040503050406030204" pitchFamily="18" charset="0"/>
+                            </a:rPr>
                           </m:ctrlPr>
                         </m:sSubPr>
                         <m:e>
                           <m:r>
-                            <a:rPr lang="en-US" i="1"/>
+                            <a:rPr lang="en-US" i="1">
+                              <a:latin typeface="Cambria Math" panose="02040503050406030204" pitchFamily="18" charset="0"/>
+                            </a:rPr>
                             <m:t>𝛼</m:t>
                           </m:r>
                         </m:e>
                         <m:sub>
                           <m:r>
-                            <a:rPr lang="en-US" i="1"/>
+                            <a:rPr lang="en-US" i="1">
+                              <a:latin typeface="Cambria Math" panose="02040503050406030204" pitchFamily="18" charset="0"/>
+                            </a:rPr>
                             <m:t>𝑡</m:t>
                           </m:r>
                         </m:sub>
                       </m:sSub>
                       <m:r>
-                        <a:rPr lang="en-US" i="1"/>
+                        <a:rPr lang="en-US" i="1">
+                          <a:latin typeface="Cambria Math" panose="02040503050406030204" pitchFamily="18" charset="0"/>
+                        </a:rPr>
                         <m:t>+</m:t>
                       </m:r>
                       <m:sSub>
                         <m:sSubPr>
                           <m:ctrlPr>
-                            <a:rPr lang="en-US" i="1"/>
+                            <a:rPr lang="en-US" i="1">
+                              <a:latin typeface="Cambria Math" panose="02040503050406030204" pitchFamily="18" charset="0"/>
+                            </a:rPr>
                           </m:ctrlPr>
                         </m:sSubPr>
                         <m:e>
                           <m:r>
-                            <a:rPr lang="en-US" i="1"/>
+                            <a:rPr lang="en-US" i="1">
+                              <a:latin typeface="Cambria Math" panose="02040503050406030204" pitchFamily="18" charset="0"/>
+                            </a:rPr>
                             <m:t>𝛽</m:t>
                           </m:r>
                         </m:e>
                         <m:sub>
                           <m:r>
-                            <a:rPr lang="en-US" i="1"/>
+                            <a:rPr lang="en-US" i="1">
+                              <a:latin typeface="Cambria Math" panose="02040503050406030204" pitchFamily="18" charset="0"/>
+                            </a:rPr>
                             <m:t>1</m:t>
                           </m:r>
                         </m:sub>
@@ -7667,27 +7706,37 @@
                       <m:sSub>
                         <m:sSubPr>
                           <m:ctrlPr>
-                            <a:rPr lang="en-US" i="1"/>
+                            <a:rPr lang="en-US" i="1">
+                              <a:latin typeface="Cambria Math" panose="02040503050406030204" pitchFamily="18" charset="0"/>
+                            </a:rPr>
                           </m:ctrlPr>
                         </m:sSubPr>
                         <m:e>
                           <m:d>
                             <m:dPr>
                               <m:ctrlPr>
-                                <a:rPr lang="en-US" i="1"/>
+                                <a:rPr lang="en-US" i="1">
+                                  <a:latin typeface="Cambria Math" panose="02040503050406030204" pitchFamily="18" charset="0"/>
+                                </a:rPr>
                               </m:ctrlPr>
                             </m:dPr>
                             <m:e>
                               <m:r>
-                                <a:rPr lang="en-US" i="1"/>
+                                <a:rPr lang="en-US" i="1">
+                                  <a:latin typeface="Cambria Math" panose="02040503050406030204" pitchFamily="18" charset="0"/>
+                                </a:rPr>
                                 <m:t>𝑃𝑟𝑒</m:t>
                               </m:r>
                               <m:r>
-                                <a:rPr lang="en-US" i="1"/>
+                                <a:rPr lang="en-US" i="1">
+                                  <a:latin typeface="Cambria Math" panose="02040503050406030204" pitchFamily="18" charset="0"/>
+                                </a:rPr>
                                 <m:t>∗</m:t>
                               </m:r>
                               <m:r>
-                                <a:rPr lang="en-US" i="1"/>
+                                <a:rPr lang="en-US" i="1">
+                                  <a:latin typeface="Cambria Math" panose="02040503050406030204" pitchFamily="18" charset="0"/>
+                                </a:rPr>
                                 <m:t>𝑃𝑜𝑣𝑒𝑟𝑡𝑦</m:t>
                               </m:r>
                             </m:e>
@@ -7695,38 +7744,52 @@
                         </m:e>
                         <m:sub>
                           <m:r>
-                            <a:rPr lang="en-US" i="1"/>
+                            <a:rPr lang="en-US" i="1">
+                              <a:latin typeface="Cambria Math" panose="02040503050406030204" pitchFamily="18" charset="0"/>
+                            </a:rPr>
                             <m:t>𝑖</m:t>
                           </m:r>
                           <m:r>
-                            <a:rPr lang="en-US" i="1"/>
+                            <a:rPr lang="en-US" i="1">
+                              <a:latin typeface="Cambria Math" panose="02040503050406030204" pitchFamily="18" charset="0"/>
+                            </a:rPr>
                             <m:t>,</m:t>
                           </m:r>
                           <m:r>
-                            <a:rPr lang="en-US" i="1"/>
+                            <a:rPr lang="en-US" i="1">
+                              <a:latin typeface="Cambria Math" panose="02040503050406030204" pitchFamily="18" charset="0"/>
+                            </a:rPr>
                             <m:t>𝑡</m:t>
                           </m:r>
                         </m:sub>
                       </m:sSub>
                       <m:r>
-                        <a:rPr lang="en-US" i="1"/>
+                        <a:rPr lang="en-US" i="1">
+                          <a:latin typeface="Cambria Math" panose="02040503050406030204" pitchFamily="18" charset="0"/>
+                        </a:rPr>
                         <m:t>+</m:t>
                       </m:r>
                       <m:sSub>
                         <m:sSubPr>
                           <m:ctrlPr>
-                            <a:rPr lang="en-US" i="1"/>
+                            <a:rPr lang="en-US" i="1">
+                              <a:latin typeface="Cambria Math" panose="02040503050406030204" pitchFamily="18" charset="0"/>
+                            </a:rPr>
                           </m:ctrlPr>
                         </m:sSubPr>
                         <m:e>
                           <m:r>
-                            <a:rPr lang="en-US" i="1"/>
+                            <a:rPr lang="en-US" i="1">
+                              <a:latin typeface="Cambria Math" panose="02040503050406030204" pitchFamily="18" charset="0"/>
+                            </a:rPr>
                             <m:t>𝛽</m:t>
                           </m:r>
                         </m:e>
                         <m:sub>
                           <m:r>
-                            <a:rPr lang="en-US" i="1"/>
+                            <a:rPr lang="en-US" i="1">
+                              <a:latin typeface="Cambria Math" panose="02040503050406030204" pitchFamily="18" charset="0"/>
+                            </a:rPr>
                             <m:t>2</m:t>
                           </m:r>
                         </m:sub>
@@ -7734,27 +7797,37 @@
                       <m:sSub>
                         <m:sSubPr>
                           <m:ctrlPr>
-                            <a:rPr lang="en-US" i="1"/>
+                            <a:rPr lang="en-US" i="1">
+                              <a:latin typeface="Cambria Math" panose="02040503050406030204" pitchFamily="18" charset="0"/>
+                            </a:rPr>
                           </m:ctrlPr>
                         </m:sSubPr>
                         <m:e>
                           <m:d>
                             <m:dPr>
                               <m:ctrlPr>
-                                <a:rPr lang="en-US" i="1"/>
+                                <a:rPr lang="en-US" i="1">
+                                  <a:latin typeface="Cambria Math" panose="02040503050406030204" pitchFamily="18" charset="0"/>
+                                </a:rPr>
                               </m:ctrlPr>
                             </m:dPr>
                             <m:e>
                               <m:r>
-                                <a:rPr lang="en-US" i="1"/>
+                                <a:rPr lang="en-US" i="1">
+                                  <a:latin typeface="Cambria Math" panose="02040503050406030204" pitchFamily="18" charset="0"/>
+                                </a:rPr>
                                 <m:t>𝑃𝑜𝑠𝑡</m:t>
                               </m:r>
                               <m:r>
-                                <a:rPr lang="en-US" i="1"/>
+                                <a:rPr lang="en-US" i="1">
+                                  <a:latin typeface="Cambria Math" panose="02040503050406030204" pitchFamily="18" charset="0"/>
+                                </a:rPr>
                                 <m:t>∗</m:t>
                               </m:r>
                               <m:r>
-                                <a:rPr lang="en-US" i="1"/>
+                                <a:rPr lang="en-US" i="1">
+                                  <a:latin typeface="Cambria Math" panose="02040503050406030204" pitchFamily="18" charset="0"/>
+                                </a:rPr>
                                 <m:t>𝑃𝑜𝑣𝑒𝑟𝑡𝑦</m:t>
                               </m:r>
                             </m:e>
@@ -7762,46 +7835,64 @@
                         </m:e>
                         <m:sub>
                           <m:r>
-                            <a:rPr lang="en-US" i="1"/>
+                            <a:rPr lang="en-US" i="1">
+                              <a:latin typeface="Cambria Math" panose="02040503050406030204" pitchFamily="18" charset="0"/>
+                            </a:rPr>
                             <m:t>𝑖</m:t>
                           </m:r>
                           <m:r>
-                            <a:rPr lang="en-US" i="1"/>
+                            <a:rPr lang="en-US" i="1">
+                              <a:latin typeface="Cambria Math" panose="02040503050406030204" pitchFamily="18" charset="0"/>
+                            </a:rPr>
                             <m:t>,</m:t>
                           </m:r>
                           <m:r>
-                            <a:rPr lang="en-US" i="1"/>
+                            <a:rPr lang="en-US" i="1">
+                              <a:latin typeface="Cambria Math" panose="02040503050406030204" pitchFamily="18" charset="0"/>
+                            </a:rPr>
                             <m:t>𝑡</m:t>
                           </m:r>
                         </m:sub>
                       </m:sSub>
                       <m:r>
-                        <a:rPr lang="en-US" i="1"/>
+                        <a:rPr lang="en-US" i="1">
+                          <a:latin typeface="Cambria Math" panose="02040503050406030204" pitchFamily="18" charset="0"/>
+                        </a:rPr>
                         <m:t>+</m:t>
                       </m:r>
                       <m:sSub>
                         <m:sSubPr>
                           <m:ctrlPr>
-                            <a:rPr lang="en-US" i="1"/>
+                            <a:rPr lang="en-US" i="1">
+                              <a:latin typeface="Cambria Math" panose="02040503050406030204" pitchFamily="18" charset="0"/>
+                            </a:rPr>
                           </m:ctrlPr>
                         </m:sSubPr>
                         <m:e>
                           <m:r>
-                            <a:rPr lang="en-US" i="1"/>
+                            <a:rPr lang="en-US" i="1">
+                              <a:latin typeface="Cambria Math" panose="02040503050406030204" pitchFamily="18" charset="0"/>
+                            </a:rPr>
                             <m:t>𝜖</m:t>
                           </m:r>
                         </m:e>
                         <m:sub>
                           <m:r>
-                            <a:rPr lang="en-US" i="1"/>
+                            <a:rPr lang="en-US" i="1">
+                              <a:latin typeface="Cambria Math" panose="02040503050406030204" pitchFamily="18" charset="0"/>
+                            </a:rPr>
                             <m:t>𝑖</m:t>
                           </m:r>
                           <m:r>
-                            <a:rPr lang="en-US" i="1"/>
+                            <a:rPr lang="en-US" i="1">
+                              <a:latin typeface="Cambria Math" panose="02040503050406030204" pitchFamily="18" charset="0"/>
+                            </a:rPr>
                             <m:t>,</m:t>
                           </m:r>
                           <m:r>
-                            <a:rPr lang="en-US" i="1"/>
+                            <a:rPr lang="en-US" i="1">
+                              <a:latin typeface="Cambria Math" panose="02040503050406030204" pitchFamily="18" charset="0"/>
+                            </a:rPr>
                             <m:t>𝑡</m:t>
                           </m:r>
                         </m:sub>
@@ -7995,7 +8086,7 @@
             </p:txBody>
           </p:sp>
         </mc:Choice>
-        <mc:Fallback>
+        <mc:Fallback xmlns="">
           <p:sp>
             <p:nvSpPr>
               <p:cNvPr id="4" name="Content Placeholder 3">
@@ -8403,8 +8494,8 @@
           </a:p>
         </p:txBody>
       </p:sp>
-      <mc:AlternateContent xmlns:mc="http://schemas.openxmlformats.org/markup-compatibility/2006">
-        <mc:Choice xmlns:a14="http://schemas.microsoft.com/office/drawing/2010/main" Requires="a14">
+      <mc:AlternateContent xmlns:mc="http://schemas.openxmlformats.org/markup-compatibility/2006" xmlns:a14="http://schemas.microsoft.com/office/drawing/2010/main">
+        <mc:Choice Requires="a14">
           <p:graphicFrame>
             <p:nvGraphicFramePr>
               <p:cNvPr id="6" name="Content Placeholder 5">
@@ -8510,8 +8601,9 @@
                               <m:sSub>
                                 <m:sSubPr>
                                   <m:ctrlPr>
-                                    <a:rPr lang="en-US" sz="1600" kern="100">
+                                    <a:rPr lang="en-US" sz="1600" i="1" kern="100">
                                       <a:effectLst/>
+                                      <a:latin typeface="Cambria Math" panose="02040503050406030204" pitchFamily="18" charset="0"/>
                                     </a:rPr>
                                   </m:ctrlPr>
                                 </m:sSubPr>
@@ -8519,6 +8611,7 @@
                                   <m:r>
                                     <a:rPr lang="en-US" sz="1600" kern="100">
                                       <a:effectLst/>
+                                      <a:latin typeface="Cambria Math" panose="02040503050406030204" pitchFamily="18" charset="0"/>
                                     </a:rPr>
                                     <m:t>𝜷</m:t>
                                   </m:r>
@@ -8527,6 +8620,7 @@
                                   <m:r>
                                     <a:rPr lang="en-US" sz="1600" kern="100">
                                       <a:effectLst/>
+                                      <a:latin typeface="Cambria Math" panose="02040503050406030204" pitchFamily="18" charset="0"/>
                                     </a:rPr>
                                     <m:t>𝟏</m:t>
                                   </m:r>
@@ -9156,7 +9250,7 @@
             </a:graphic>
           </p:graphicFrame>
         </mc:Choice>
-        <mc:Fallback>
+        <mc:Fallback xmlns="">
           <p:graphicFrame>
             <p:nvGraphicFramePr>
               <p:cNvPr id="6" name="Content Placeholder 5">
@@ -11056,8 +11150,8 @@
           </a:p>
         </p:txBody>
       </p:sp>
-      <mc:AlternateContent xmlns:mc="http://schemas.openxmlformats.org/markup-compatibility/2006">
-        <mc:Choice xmlns:a14="http://schemas.microsoft.com/office/drawing/2010/main" Requires="a14">
+      <mc:AlternateContent xmlns:mc="http://schemas.openxmlformats.org/markup-compatibility/2006" xmlns:a14="http://schemas.microsoft.com/office/drawing/2010/main">
+        <mc:Choice Requires="a14">
           <p:sp>
             <p:nvSpPr>
               <p:cNvPr id="4" name="Content Placeholder 3">
@@ -11093,18 +11187,24 @@
                     <m:sSub>
                       <m:sSubPr>
                         <m:ctrlPr>
-                          <a:rPr lang="en-US" i="1"/>
+                          <a:rPr lang="en-US" i="1">
+                            <a:latin typeface="Cambria Math" panose="02040503050406030204" pitchFamily="18" charset="0"/>
+                          </a:rPr>
                         </m:ctrlPr>
                       </m:sSubPr>
                       <m:e>
                         <m:r>
-                          <a:rPr lang="en-US" i="1"/>
+                          <a:rPr lang="en-US" i="1">
+                            <a:latin typeface="Cambria Math" panose="02040503050406030204" pitchFamily="18" charset="0"/>
+                          </a:rPr>
                           <m:t>𝛽</m:t>
                         </m:r>
                       </m:e>
                       <m:sub>
                         <m:r>
-                          <a:rPr lang="en-US" i="1"/>
+                          <a:rPr lang="en-US" i="1">
+                            <a:latin typeface="Cambria Math" panose="02040503050406030204" pitchFamily="18" charset="0"/>
+                          </a:rPr>
                           <m:t>2</m:t>
                         </m:r>
                       </m:sub>
@@ -11131,7 +11231,7 @@
             </p:txBody>
           </p:sp>
         </mc:Choice>
-        <mc:Fallback>
+        <mc:Fallback xmlns="">
           <p:sp>
             <p:nvSpPr>
               <p:cNvPr id="4" name="Content Placeholder 3">
@@ -11175,8 +11275,8 @@
           </p:sp>
         </mc:Fallback>
       </mc:AlternateContent>
-      <mc:AlternateContent xmlns:mc="http://schemas.openxmlformats.org/markup-compatibility/2006">
-        <mc:Choice xmlns:a14="http://schemas.microsoft.com/office/drawing/2010/main" Requires="a14">
+      <mc:AlternateContent xmlns:mc="http://schemas.openxmlformats.org/markup-compatibility/2006" xmlns:a14="http://schemas.microsoft.com/office/drawing/2010/main">
+        <mc:Choice Requires="a14">
           <p:graphicFrame>
             <p:nvGraphicFramePr>
               <p:cNvPr id="7" name="Table 6">
@@ -11296,8 +11396,9 @@
                               <m:sSub>
                                 <m:sSubPr>
                                   <m:ctrlPr>
-                                    <a:rPr lang="en-US" sz="1200" kern="100">
+                                    <a:rPr lang="en-US" sz="1200" i="1" kern="100">
                                       <a:effectLst/>
+                                      <a:latin typeface="Cambria Math" panose="02040503050406030204" pitchFamily="18" charset="0"/>
                                     </a:rPr>
                                   </m:ctrlPr>
                                 </m:sSubPr>
@@ -11305,6 +11406,7 @@
                                   <m:r>
                                     <a:rPr lang="en-US" sz="1200" kern="100">
                                       <a:effectLst/>
+                                      <a:latin typeface="Cambria Math" panose="02040503050406030204" pitchFamily="18" charset="0"/>
                                     </a:rPr>
                                     <m:t>𝜷</m:t>
                                   </m:r>
@@ -11313,6 +11415,7 @@
                                   <m:r>
                                     <a:rPr lang="en-US" sz="1200" kern="100">
                                       <a:effectLst/>
+                                      <a:latin typeface="Cambria Math" panose="02040503050406030204" pitchFamily="18" charset="0"/>
                                     </a:rPr>
                                     <m:t>𝟏</m:t>
                                   </m:r>
@@ -11360,8 +11463,9 @@
                               <m:sSub>
                                 <m:sSubPr>
                                   <m:ctrlPr>
-                                    <a:rPr lang="en-US" sz="1200" kern="100">
+                                    <a:rPr lang="en-US" sz="1200" i="1" kern="100">
                                       <a:effectLst/>
+                                      <a:latin typeface="Cambria Math" panose="02040503050406030204" pitchFamily="18" charset="0"/>
                                     </a:rPr>
                                   </m:ctrlPr>
                                 </m:sSubPr>
@@ -11369,6 +11473,7 @@
                                   <m:r>
                                     <a:rPr lang="en-US" sz="1200" kern="100">
                                       <a:effectLst/>
+                                      <a:latin typeface="Cambria Math" panose="02040503050406030204" pitchFamily="18" charset="0"/>
                                     </a:rPr>
                                     <m:t>𝜷</m:t>
                                   </m:r>
@@ -11377,6 +11482,7 @@
                                   <m:r>
                                     <a:rPr lang="en-US" sz="1200" kern="100">
                                       <a:effectLst/>
+                                      <a:latin typeface="Cambria Math" panose="02040503050406030204" pitchFamily="18" charset="0"/>
                                     </a:rPr>
                                     <m:t>𝟐</m:t>
                                   </m:r>
@@ -12250,7 +12356,7 @@
             </a:graphic>
           </p:graphicFrame>
         </mc:Choice>
-        <mc:Fallback>
+        <mc:Fallback xmlns="">
           <p:graphicFrame>
             <p:nvGraphicFramePr>
               <p:cNvPr id="7" name="Table 6">
@@ -14562,6 +14668,7 @@
             </a:r>
           </a:p>
           <a:p>
+            <a:pPr lvl="1"/>
             <a:r>
               <a:rPr lang="en-US" dirty="0"/>
               <a:t>Change in test score scaling caused significant information loss. An expanded time frame would benefit deeper analysis on pre- and post-pandemic trends.</a:t>
@@ -20121,6 +20228,15 @@
 </file>
 
 <file path=customXml/item1.xml><?xml version="1.0" encoding="utf-8"?>
+<?mso-contentType ?>
+<FormTemplates xmlns="http://schemas.microsoft.com/sharepoint/v3/contenttype/forms">
+  <Display>DocumentLibraryForm</Display>
+  <Edit>DocumentLibraryForm</Edit>
+  <New>DocumentLibraryForm</New>
+</FormTemplates>
+</file>
+
+<file path=customXml/item2.xml><?xml version="1.0" encoding="utf-8"?>
 <ct:contentTypeSchema xmlns:ct="http://schemas.microsoft.com/office/2006/metadata/contentType" xmlns:ma="http://schemas.microsoft.com/office/2006/metadata/properties/metaAttributes" ct:_="" ma:_="" ma:contentTypeName="Document" ma:contentTypeID="0x01010029A2C74D4EF0DD4A9DAD7848AA4454B4" ma:contentTypeVersion="7" ma:contentTypeDescription="Create a new document." ma:contentTypeScope="" ma:versionID="ca25f40ebe90d9065487cf317404a2f7">
   <xsd:schema xmlns:xsd="http://www.w3.org/2001/XMLSchema" xmlns:xs="http://www.w3.org/2001/XMLSchema" xmlns:p="http://schemas.microsoft.com/office/2006/metadata/properties" xmlns:ns2="91e18175-f32a-48e9-9014-05a836c772f7" targetNamespace="http://schemas.microsoft.com/office/2006/metadata/properties" ma:root="true" ma:fieldsID="8dd2dac8d2fcf2c405ea9ba65658d9ff" ns2:_="">
     <xsd:import namespace="91e18175-f32a-48e9-9014-05a836c772f7"/>
@@ -20282,22 +20398,21 @@
 </ct:contentTypeSchema>
 </file>
 
-<file path=customXml/item2.xml><?xml version="1.0" encoding="utf-8"?>
+<file path=customXml/item3.xml><?xml version="1.0" encoding="utf-8"?>
 <p:properties xmlns:p="http://schemas.microsoft.com/office/2006/metadata/properties" xmlns:xsi="http://www.w3.org/2001/XMLSchema-instance" xmlns:pc="http://schemas.microsoft.com/office/infopath/2007/PartnerControls">
   <documentManagement/>
 </p:properties>
 </file>
 
-<file path=customXml/item3.xml><?xml version="1.0" encoding="utf-8"?>
-<?mso-contentType ?>
-<FormTemplates xmlns="http://schemas.microsoft.com/sharepoint/v3/contenttype/forms">
-  <Display>DocumentLibraryForm</Display>
-  <Edit>DocumentLibraryForm</Edit>
-  <New>DocumentLibraryForm</New>
-</FormTemplates>
+<file path=customXml/itemProps1.xml><?xml version="1.0" encoding="utf-8"?>
+<ds:datastoreItem xmlns:ds="http://schemas.openxmlformats.org/officeDocument/2006/customXml" ds:itemID="{A14B8143-C3D6-460D-830C-A8DBEE85511A}">
+  <ds:schemaRefs>
+    <ds:schemaRef ds:uri="http://schemas.microsoft.com/sharepoint/v3/contenttype/forms"/>
+  </ds:schemaRefs>
+</ds:datastoreItem>
 </file>
 
-<file path=customXml/itemProps1.xml><?xml version="1.0" encoding="utf-8"?>
+<file path=customXml/itemProps2.xml><?xml version="1.0" encoding="utf-8"?>
 <ds:datastoreItem xmlns:ds="http://schemas.openxmlformats.org/officeDocument/2006/customXml" ds:itemID="{5C21CEF2-29F0-40A3-81C4-07699F1E22D0}">
   <ds:schemaRefs>
     <ds:schemaRef ds:uri="http://schemas.microsoft.com/office/2006/metadata/contentType"/>
@@ -20315,7 +20430,7 @@
 </ds:datastoreItem>
 </file>
 
-<file path=customXml/itemProps2.xml><?xml version="1.0" encoding="utf-8"?>
+<file path=customXml/itemProps3.xml><?xml version="1.0" encoding="utf-8"?>
 <ds:datastoreItem xmlns:ds="http://schemas.openxmlformats.org/officeDocument/2006/customXml" ds:itemID="{097FFD54-27B0-415C-8654-D843242BD071}">
   <ds:schemaRefs>
     <ds:schemaRef ds:uri="http://www.w3.org/XML/1998/namespace"/>
@@ -20328,12 +20443,4 @@
     <ds:schemaRef ds:uri="http://purl.org/dc/dcmitype/"/>
   </ds:schemaRefs>
 </ds:datastoreItem>
-</file>
-
-<file path=customXml/itemProps3.xml><?xml version="1.0" encoding="utf-8"?>
-<ds:datastoreItem xmlns:ds="http://schemas.openxmlformats.org/officeDocument/2006/customXml" ds:itemID="{A14B8143-C3D6-460D-830C-A8DBEE85511A}">
-  <ds:schemaRefs>
-    <ds:schemaRef ds:uri="http://schemas.microsoft.com/sharepoint/v3/contenttype/forms"/>
-  </ds:schemaRefs>
-</ds:datastoreItem>
 </file>
</xml_diff>

<commit_message>
Updated final presentation, adjustments to title slide
</commit_message>
<xml_diff>
--- a/Final_Products/Masters_Capstone_Final_Presentation.pptx
+++ b/Final_Products/Masters_Capstone_Final_Presentation.pptx
@@ -198,6 +198,7 @@
 <p1510:revInfo xmlns:a="http://schemas.openxmlformats.org/drawingml/2006/main" xmlns:r="http://schemas.openxmlformats.org/officeDocument/2006/relationships" xmlns:p1510="http://schemas.microsoft.com/office/powerpoint/2015/10/main">
   <p1510:revLst>
     <p1510:client id="{33F4F4BD-627D-48A9-9070-FED05580ECF7}" v="21" dt="2026-05-08T04:37:14.481"/>
+    <p1510:client id="{F21DB396-E457-47D9-901A-C57B54C956FE}" v="1" dt="2026-05-08T19:12:58.892"/>
   </p1510:revLst>
 </p1510:revInfo>
 </file>
@@ -207,10 +208,25 @@
   <pc:docChgLst>
     <pc:chgData name="Madison Jones" userId="4347cae8-7c2b-4706-9465-46f5e461052a" providerId="ADAL" clId="{23AD2B71-142B-4412-B515-82A4DB346E58}"/>
     <pc:docChg chg="undo custSel addSld delSld modSld sldOrd">
-      <pc:chgData name="Madison Jones" userId="4347cae8-7c2b-4706-9465-46f5e461052a" providerId="ADAL" clId="{23AD2B71-142B-4412-B515-82A4DB346E58}" dt="2026-05-08T16:42:32.978" v="5148" actId="15"/>
+      <pc:chgData name="Madison Jones" userId="4347cae8-7c2b-4706-9465-46f5e461052a" providerId="ADAL" clId="{23AD2B71-142B-4412-B515-82A4DB346E58}" dt="2026-05-08T19:14:28.104" v="5251" actId="20577"/>
       <pc:docMkLst>
         <pc:docMk/>
       </pc:docMkLst>
+      <pc:sldChg chg="addSp modSp mod">
+        <pc:chgData name="Madison Jones" userId="4347cae8-7c2b-4706-9465-46f5e461052a" providerId="ADAL" clId="{23AD2B71-142B-4412-B515-82A4DB346E58}" dt="2026-05-08T19:14:28.104" v="5251" actId="20577"/>
+        <pc:sldMkLst>
+          <pc:docMk/>
+          <pc:sldMk cId="160672004" sldId="512"/>
+        </pc:sldMkLst>
+        <pc:spChg chg="add mod">
+          <ac:chgData name="Madison Jones" userId="4347cae8-7c2b-4706-9465-46f5e461052a" providerId="ADAL" clId="{23AD2B71-142B-4412-B515-82A4DB346E58}" dt="2026-05-08T19:14:28.104" v="5251" actId="20577"/>
+          <ac:spMkLst>
+            <pc:docMk/>
+            <pc:sldMk cId="160672004" sldId="512"/>
+            <ac:spMk id="5" creationId="{F8C6225F-28C4-5A9B-1CE3-0B10E6D7FCA3}"/>
+          </ac:spMkLst>
+        </pc:spChg>
+      </pc:sldChg>
       <pc:sldChg chg="modSp mod">
         <pc:chgData name="Madison Jones" userId="4347cae8-7c2b-4706-9465-46f5e461052a" providerId="ADAL" clId="{23AD2B71-142B-4412-B515-82A4DB346E58}" dt="2026-05-08T03:57:11.530" v="2720" actId="20577"/>
         <pc:sldMkLst>
@@ -6179,6 +6195,211 @@
         </p:blipFill>
         <p:spPr/>
       </p:pic>
+      <p:sp>
+        <p:nvSpPr>
+          <p:cNvPr id="5" name="Subtitle 2">
+            <a:extLst>
+              <a:ext uri="{FF2B5EF4-FFF2-40B4-BE49-F238E27FC236}">
+                <a16:creationId xmlns:a16="http://schemas.microsoft.com/office/drawing/2014/main" id="{F8C6225F-28C4-5A9B-1CE3-0B10E6D7FCA3}"/>
+              </a:ext>
+            </a:extLst>
+          </p:cNvPr>
+          <p:cNvSpPr txBox="1">
+            <a:spLocks/>
+          </p:cNvSpPr>
+          <p:nvPr/>
+        </p:nvSpPr>
+        <p:spPr>
+          <a:xfrm>
+            <a:off x="1090839" y="6016179"/>
+            <a:ext cx="10264775" cy="407460"/>
+          </a:xfrm>
+          <a:prstGeom prst="rect">
+            <a:avLst/>
+          </a:prstGeom>
+        </p:spPr>
+        <p:txBody>
+          <a:bodyPr vert="horz" lIns="0" tIns="0" rIns="0" bIns="0" rtlCol="0">
+            <a:noAutofit/>
+          </a:bodyPr>
+          <a:lstStyle>
+            <a:lvl1pPr marL="0" indent="0" algn="ctr" defTabSz="914400" rtl="0" eaLnBrk="1" latinLnBrk="0" hangingPunct="1">
+              <a:lnSpc>
+                <a:spcPct val="100000"/>
+              </a:lnSpc>
+              <a:spcBef>
+                <a:spcPts val="1000"/>
+              </a:spcBef>
+              <a:buFont typeface="Arial" panose="020B0604020202020204" pitchFamily="34" charset="0"/>
+              <a:buNone/>
+              <a:defRPr sz="2400" b="0" i="0" kern="1200">
+                <a:solidFill>
+                  <a:schemeClr val="bg1"/>
+                </a:solidFill>
+                <a:latin typeface="+mn-lt"/>
+                <a:ea typeface="Tahoma" panose="020B0604030504040204" pitchFamily="34" charset="0"/>
+                <a:cs typeface="Tahoma" panose="020B0604030504040204" pitchFamily="34" charset="0"/>
+              </a:defRPr>
+            </a:lvl1pPr>
+            <a:lvl2pPr marL="457200" indent="0" algn="ctr" defTabSz="914400" rtl="0" eaLnBrk="1" latinLnBrk="0" hangingPunct="1">
+              <a:lnSpc>
+                <a:spcPct val="100000"/>
+              </a:lnSpc>
+              <a:spcBef>
+                <a:spcPts val="500"/>
+              </a:spcBef>
+              <a:buFont typeface="Roboto" panose="02000000000000000000" pitchFamily="2" charset="0"/>
+              <a:buNone/>
+              <a:defRPr sz="2000" kern="1200">
+                <a:solidFill>
+                  <a:schemeClr val="tx1"/>
+                </a:solidFill>
+                <a:latin typeface="+mn-lt"/>
+                <a:ea typeface="Roboto" panose="02000000000000000000" pitchFamily="2" charset="0"/>
+                <a:cs typeface="Arial" panose="020B0604020202020204" pitchFamily="34" charset="0"/>
+              </a:defRPr>
+            </a:lvl2pPr>
+            <a:lvl3pPr marL="914400" indent="0" algn="ctr" defTabSz="914400" rtl="0" eaLnBrk="1" latinLnBrk="0" hangingPunct="1">
+              <a:lnSpc>
+                <a:spcPct val="100000"/>
+              </a:lnSpc>
+              <a:spcBef>
+                <a:spcPts val="500"/>
+              </a:spcBef>
+              <a:buFont typeface="Arial" panose="020B0604020202020204" pitchFamily="34" charset="0"/>
+              <a:buNone/>
+              <a:defRPr sz="1800" kern="1200">
+                <a:solidFill>
+                  <a:schemeClr val="tx1"/>
+                </a:solidFill>
+                <a:latin typeface="+mn-lt"/>
+                <a:ea typeface="Roboto" panose="02000000000000000000" pitchFamily="2" charset="0"/>
+                <a:cs typeface="Arial" panose="020B0604020202020204" pitchFamily="34" charset="0"/>
+              </a:defRPr>
+            </a:lvl3pPr>
+            <a:lvl4pPr marL="1371600" indent="0" algn="ctr" defTabSz="914400" rtl="0" eaLnBrk="1" latinLnBrk="0" hangingPunct="1">
+              <a:lnSpc>
+                <a:spcPct val="100000"/>
+              </a:lnSpc>
+              <a:spcBef>
+                <a:spcPts val="500"/>
+              </a:spcBef>
+              <a:buFont typeface="Arial" panose="020B0604020202020204" pitchFamily="34" charset="0"/>
+              <a:buNone/>
+              <a:defRPr sz="1600" kern="1200">
+                <a:solidFill>
+                  <a:schemeClr val="tx1"/>
+                </a:solidFill>
+                <a:latin typeface="+mn-lt"/>
+                <a:ea typeface="Roboto" panose="02000000000000000000" pitchFamily="2" charset="0"/>
+                <a:cs typeface="Arial" panose="020B0604020202020204" pitchFamily="34" charset="0"/>
+              </a:defRPr>
+            </a:lvl4pPr>
+            <a:lvl5pPr marL="1828800" indent="0" algn="ctr" defTabSz="914400" rtl="0" eaLnBrk="1" latinLnBrk="0" hangingPunct="1">
+              <a:lnSpc>
+                <a:spcPct val="100000"/>
+              </a:lnSpc>
+              <a:spcBef>
+                <a:spcPts val="500"/>
+              </a:spcBef>
+              <a:buFont typeface="Arial" panose="020B0604020202020204" pitchFamily="34" charset="0"/>
+              <a:buNone/>
+              <a:defRPr sz="1600" kern="1200">
+                <a:solidFill>
+                  <a:schemeClr val="tx1"/>
+                </a:solidFill>
+                <a:latin typeface="+mn-lt"/>
+                <a:ea typeface="Roboto" panose="02000000000000000000" pitchFamily="2" charset="0"/>
+                <a:cs typeface="Arial" panose="020B0604020202020204" pitchFamily="34" charset="0"/>
+              </a:defRPr>
+            </a:lvl5pPr>
+            <a:lvl6pPr marL="2286000" indent="0" algn="ctr" defTabSz="914400" rtl="0" eaLnBrk="1" latinLnBrk="0" hangingPunct="1">
+              <a:lnSpc>
+                <a:spcPct val="90000"/>
+              </a:lnSpc>
+              <a:spcBef>
+                <a:spcPts val="500"/>
+              </a:spcBef>
+              <a:buFont typeface="Arial" panose="020B0604020202020204" pitchFamily="34" charset="0"/>
+              <a:buNone/>
+              <a:defRPr sz="1600" kern="1200">
+                <a:solidFill>
+                  <a:schemeClr val="tx1"/>
+                </a:solidFill>
+                <a:latin typeface="+mn-lt"/>
+                <a:ea typeface="+mn-ea"/>
+                <a:cs typeface="+mn-cs"/>
+              </a:defRPr>
+            </a:lvl6pPr>
+            <a:lvl7pPr marL="2743200" indent="0" algn="ctr" defTabSz="914400" rtl="0" eaLnBrk="1" latinLnBrk="0" hangingPunct="1">
+              <a:lnSpc>
+                <a:spcPct val="90000"/>
+              </a:lnSpc>
+              <a:spcBef>
+                <a:spcPts val="500"/>
+              </a:spcBef>
+              <a:buFont typeface="Arial" panose="020B0604020202020204" pitchFamily="34" charset="0"/>
+              <a:buNone/>
+              <a:defRPr sz="1600" kern="1200">
+                <a:solidFill>
+                  <a:schemeClr val="tx1"/>
+                </a:solidFill>
+                <a:latin typeface="+mn-lt"/>
+                <a:ea typeface="+mn-ea"/>
+                <a:cs typeface="+mn-cs"/>
+              </a:defRPr>
+            </a:lvl7pPr>
+            <a:lvl8pPr marL="3200400" indent="0" algn="ctr" defTabSz="914400" rtl="0" eaLnBrk="1" latinLnBrk="0" hangingPunct="1">
+              <a:lnSpc>
+                <a:spcPct val="90000"/>
+              </a:lnSpc>
+              <a:spcBef>
+                <a:spcPts val="500"/>
+              </a:spcBef>
+              <a:buFont typeface="Arial" panose="020B0604020202020204" pitchFamily="34" charset="0"/>
+              <a:buNone/>
+              <a:defRPr sz="1600" kern="1200">
+                <a:solidFill>
+                  <a:schemeClr val="tx1"/>
+                </a:solidFill>
+                <a:latin typeface="+mn-lt"/>
+                <a:ea typeface="+mn-ea"/>
+                <a:cs typeface="+mn-cs"/>
+              </a:defRPr>
+            </a:lvl8pPr>
+            <a:lvl9pPr marL="3657600" indent="0" algn="ctr" defTabSz="914400" rtl="0" eaLnBrk="1" latinLnBrk="0" hangingPunct="1">
+              <a:lnSpc>
+                <a:spcPct val="90000"/>
+              </a:lnSpc>
+              <a:spcBef>
+                <a:spcPts val="500"/>
+              </a:spcBef>
+              <a:buFont typeface="Arial" panose="020B0604020202020204" pitchFamily="34" charset="0"/>
+              <a:buNone/>
+              <a:defRPr sz="1600" kern="1200">
+                <a:solidFill>
+                  <a:schemeClr val="tx1"/>
+                </a:solidFill>
+                <a:latin typeface="+mn-lt"/>
+                <a:ea typeface="+mn-ea"/>
+                <a:cs typeface="+mn-cs"/>
+              </a:defRPr>
+            </a:lvl9pPr>
+          </a:lstStyle>
+          <a:p>
+            <a:r>
+              <a:rPr lang="en-US" sz="1600" b="1" dirty="0"/>
+              <a:t>Master’s Project Final Presentation</a:t>
+            </a:r>
+          </a:p>
+          <a:p>
+            <a:r>
+              <a:rPr lang="en-US" sz="1600" dirty="0"/>
+              <a:t>56:219:603:91</a:t>
+            </a:r>
+          </a:p>
+        </p:txBody>
+      </p:sp>
     </p:spTree>
     <p:extLst>
       <p:ext uri="{BB962C8B-B14F-4D97-AF65-F5344CB8AC3E}">
@@ -20228,6 +20449,12 @@
 </file>
 
 <file path=customXml/item1.xml><?xml version="1.0" encoding="utf-8"?>
+<p:properties xmlns:p="http://schemas.microsoft.com/office/2006/metadata/properties" xmlns:xsi="http://www.w3.org/2001/XMLSchema-instance" xmlns:pc="http://schemas.microsoft.com/office/infopath/2007/PartnerControls">
+  <documentManagement/>
+</p:properties>
+</file>
+
+<file path=customXml/item2.xml><?xml version="1.0" encoding="utf-8"?>
 <?mso-contentType ?>
 <FormTemplates xmlns="http://schemas.microsoft.com/sharepoint/v3/contenttype/forms">
   <Display>DocumentLibraryForm</Display>
@@ -20236,7 +20463,7 @@
 </FormTemplates>
 </file>
 
-<file path=customXml/item2.xml><?xml version="1.0" encoding="utf-8"?>
+<file path=customXml/item3.xml><?xml version="1.0" encoding="utf-8"?>
 <ct:contentTypeSchema xmlns:ct="http://schemas.microsoft.com/office/2006/metadata/contentType" xmlns:ma="http://schemas.microsoft.com/office/2006/metadata/properties/metaAttributes" ct:_="" ma:_="" ma:contentTypeName="Document" ma:contentTypeID="0x01010029A2C74D4EF0DD4A9DAD7848AA4454B4" ma:contentTypeVersion="7" ma:contentTypeDescription="Create a new document." ma:contentTypeScope="" ma:versionID="ca25f40ebe90d9065487cf317404a2f7">
   <xsd:schema xmlns:xsd="http://www.w3.org/2001/XMLSchema" xmlns:xs="http://www.w3.org/2001/XMLSchema" xmlns:p="http://schemas.microsoft.com/office/2006/metadata/properties" xmlns:ns2="91e18175-f32a-48e9-9014-05a836c772f7" targetNamespace="http://schemas.microsoft.com/office/2006/metadata/properties" ma:root="true" ma:fieldsID="8dd2dac8d2fcf2c405ea9ba65658d9ff" ns2:_="">
     <xsd:import namespace="91e18175-f32a-48e9-9014-05a836c772f7"/>
@@ -20398,13 +20625,22 @@
 </ct:contentTypeSchema>
 </file>
 
-<file path=customXml/item3.xml><?xml version="1.0" encoding="utf-8"?>
-<p:properties xmlns:p="http://schemas.microsoft.com/office/2006/metadata/properties" xmlns:xsi="http://www.w3.org/2001/XMLSchema-instance" xmlns:pc="http://schemas.microsoft.com/office/infopath/2007/PartnerControls">
-  <documentManagement/>
-</p:properties>
+<file path=customXml/itemProps1.xml><?xml version="1.0" encoding="utf-8"?>
+<ds:datastoreItem xmlns:ds="http://schemas.openxmlformats.org/officeDocument/2006/customXml" ds:itemID="{097FFD54-27B0-415C-8654-D843242BD071}">
+  <ds:schemaRefs>
+    <ds:schemaRef ds:uri="http://www.w3.org/XML/1998/namespace"/>
+    <ds:schemaRef ds:uri="http://schemas.microsoft.com/office/2006/documentManagement/types"/>
+    <ds:schemaRef ds:uri="http://schemas.microsoft.com/office/infopath/2007/PartnerControls"/>
+    <ds:schemaRef ds:uri="http://schemas.microsoft.com/office/2006/metadata/properties"/>
+    <ds:schemaRef ds:uri="http://schemas.openxmlformats.org/package/2006/metadata/core-properties"/>
+    <ds:schemaRef ds:uri="http://purl.org/dc/terms/"/>
+    <ds:schemaRef ds:uri="http://purl.org/dc/elements/1.1/"/>
+    <ds:schemaRef ds:uri="http://purl.org/dc/dcmitype/"/>
+  </ds:schemaRefs>
+</ds:datastoreItem>
 </file>
 
-<file path=customXml/itemProps1.xml><?xml version="1.0" encoding="utf-8"?>
+<file path=customXml/itemProps2.xml><?xml version="1.0" encoding="utf-8"?>
 <ds:datastoreItem xmlns:ds="http://schemas.openxmlformats.org/officeDocument/2006/customXml" ds:itemID="{A14B8143-C3D6-460D-830C-A8DBEE85511A}">
   <ds:schemaRefs>
     <ds:schemaRef ds:uri="http://schemas.microsoft.com/sharepoint/v3/contenttype/forms"/>
@@ -20412,7 +20648,7 @@
 </ds:datastoreItem>
 </file>
 
-<file path=customXml/itemProps2.xml><?xml version="1.0" encoding="utf-8"?>
+<file path=customXml/itemProps3.xml><?xml version="1.0" encoding="utf-8"?>
 <ds:datastoreItem xmlns:ds="http://schemas.openxmlformats.org/officeDocument/2006/customXml" ds:itemID="{5C21CEF2-29F0-40A3-81C4-07699F1E22D0}">
   <ds:schemaRefs>
     <ds:schemaRef ds:uri="http://schemas.microsoft.com/office/2006/metadata/contentType"/>
@@ -20428,19 +20664,4 @@
     <ds:schemaRef ds:uri="http://schemas.microsoft.com/internal/obd"/>
   </ds:schemaRefs>
 </ds:datastoreItem>
-</file>
-
-<file path=customXml/itemProps3.xml><?xml version="1.0" encoding="utf-8"?>
-<ds:datastoreItem xmlns:ds="http://schemas.openxmlformats.org/officeDocument/2006/customXml" ds:itemID="{097FFD54-27B0-415C-8654-D843242BD071}">
-  <ds:schemaRefs>
-    <ds:schemaRef ds:uri="http://www.w3.org/XML/1998/namespace"/>
-    <ds:schemaRef ds:uri="http://schemas.microsoft.com/office/2006/documentManagement/types"/>
-    <ds:schemaRef ds:uri="http://schemas.microsoft.com/office/infopath/2007/PartnerControls"/>
-    <ds:schemaRef ds:uri="http://schemas.microsoft.com/office/2006/metadata/properties"/>
-    <ds:schemaRef ds:uri="http://schemas.openxmlformats.org/package/2006/metadata/core-properties"/>
-    <ds:schemaRef ds:uri="http://purl.org/dc/terms/"/>
-    <ds:schemaRef ds:uri="http://purl.org/dc/elements/1.1/"/>
-    <ds:schemaRef ds:uri="http://purl.org/dc/dcmitype/"/>
-  </ds:schemaRefs>
-</ds:datastoreItem>
 </file>
</xml_diff>